<commit_message>
Align team pitch with the organisers' five shortlisting questions
Builds on the presenter's own edits: each slide now states the question
it answers, with explicit why-AI, GI-AI4AFS interoperability and demo
points.

Co-Authored-By: Claude Opus 5.5 <noreply@anthropic.com>
Claude-Session: https://claude.ai/code/session_01NdWoCHRdg4cxRbomfuAgtg
</commit_message>
<xml_diff>
--- a/MuDAS-AI_Initial_Team_Pitch.pptx
+++ b/MuDAS-AI_Initial_Team_Pitch.pptx
@@ -5,14 +5,14 @@
     <p:sldMasterId id="2147483648" r:id="rId1"/>
   </p:sldMasterIdLst>
   <p:notesMasterIdLst>
-    <p:notesMasterId r:id="rId6"/>
+    <p:notesMasterId r:id="rId7"/>
   </p:notesMasterIdLst>
   <p:sldIdLst>
     <p:sldId id="256" r:id="rId2"/>
     <p:sldId id="258" r:id="rId3"/>
     <p:sldId id="260" r:id="rId4"/>
     <p:sldId id="259" r:id="rId5"/>
-    <p:sldId id="261" r:id="rId11"/>
+    <p:sldId id="261" r:id="rId6"/>
   </p:sldIdLst>
   <p:sldSz cx="12192000" cy="6858000"/>
   <p:notesSz cx="6858000" cy="9144000"/>
@@ -3999,47 +3999,6 @@
       </p:sp>
       <p:sp>
         <p:nvSpPr>
-          <p:cNvPr id="10" name="TextBox 9">
-            <a:extLst>
-              <a:ext uri="{FF2B5EF4-FFF2-40B4-BE49-F238E27FC236}">
-                <a16:creationId xmlns:a16="http://schemas.microsoft.com/office/drawing/2014/main" id="{55E02202-B357-B67A-3F16-D105EDF2FF5A}"/>
-              </a:ext>
-            </a:extLst>
-          </p:cNvPr>
-          <p:cNvSpPr txBox="1"/>
-          <p:nvPr/>
-        </p:nvSpPr>
-        <p:spPr>
-          <a:xfrm>
-            <a:off x="932688" y="3600000"/>
-            <a:ext cx="7300000" cy="369332"/>
-          </a:xfrm>
-          <a:prstGeom prst="rect">
-            <a:avLst/>
-          </a:prstGeom>
-          <a:noFill/>
-        </p:spPr>
-        <p:txBody>
-          <a:bodyPr wrap="square">
-            <a:spAutoFit/>
-          </a:bodyPr>
-          <a:lstStyle/>
-          <a:p>
-            <a:pPr algn="l"/>
-            <a:r>
-              <a:rPr lang="en-US" sz="1300" b="1" i="0" dirty="0">
-                <a:solidFill>
-                  <a:srgbClr val="FFFFFF"/>
-                </a:solidFill>
-                <a:latin typeface="Aptos"/>
-              </a:rPr>
-              <a:t>Solution: Multimodal UAV + AI for white rust severity mapping in mustard</a:t>
-            </a:r>
-          </a:p>
-        </p:txBody>
-      </p:sp>
-      <p:sp>
-        <p:nvSpPr>
           <p:cNvPr id="11" name="TextBox 10">
             <a:extLst>
               <a:ext uri="{FF2B5EF4-FFF2-40B4-BE49-F238E27FC236}">
@@ -4052,8 +4011,8 @@
         </p:nvSpPr>
         <p:spPr>
           <a:xfrm>
-            <a:off x="932688" y="4060000"/>
-            <a:ext cx="7300000" cy="369332"/>
+            <a:off x="932688" y="3758973"/>
+            <a:ext cx="7300000" cy="954107"/>
           </a:xfrm>
           <a:prstGeom prst="rect">
             <a:avLst/>
@@ -4074,11 +4033,28 @@
                 </a:solidFill>
                 <a:latin typeface="Aptos"/>
               </a:rPr>
-              <a:t>Thematic Area: Crop Intelligence and Decision Support</a:t>
+              <a:t>Thematic Area: </a:t>
+            </a:r>
+            <a:r>
+              <a:rPr lang="en-US" sz="1400" b="1" i="0" dirty="0">
+                <a:solidFill>
+                  <a:srgbClr val="E0E8E9"/>
+                </a:solidFill>
+                <a:latin typeface="Aptos"/>
+              </a:rPr>
+              <a:t>Crop Intelligence and Decision Support</a:t>
             </a:r>
           </a:p>
           <a:p>
             <a:pPr algn="l"/>
+            <a:endParaRPr lang="en-US" sz="1400" b="1" i="0" dirty="0">
+              <a:solidFill>
+                <a:srgbClr val="E0E8E9"/>
+              </a:solidFill>
+              <a:latin typeface="Aptos"/>
+            </a:endParaRPr>
+          </a:p>
+          <a:p>
             <a:r>
               <a:rPr lang="en-US" sz="1400" b="0" i="0" dirty="0">
                 <a:solidFill>
@@ -4086,8 +4062,54 @@
                 </a:solidFill>
                 <a:latin typeface="Aptos"/>
               </a:rPr>
-              <a:t>Presenter: Animesh Panda, PhD Scholar, ICAR-IARI, New Delhi</a:t>
-            </a:r>
+              <a:t>Presenter: Animesh Panda, </a:t>
+            </a:r>
+            <a:r>
+              <a:rPr lang="en-IN" sz="1400" dirty="0">
+                <a:solidFill>
+                  <a:srgbClr val="E0E8E9"/>
+                </a:solidFill>
+              </a:rPr>
+              <a:t>Rabi N Sahoo, Rajeev Ranjan, </a:t>
+            </a:r>
+            <a:r>
+              <a:rPr lang="en-IN" sz="1400" dirty="0" err="1">
+                <a:solidFill>
+                  <a:srgbClr val="E0E8E9"/>
+                </a:solidFill>
+              </a:rPr>
+              <a:t>Rejith</a:t>
+            </a:r>
+            <a:r>
+              <a:rPr lang="en-IN" sz="1400" dirty="0">
+                <a:solidFill>
+                  <a:srgbClr val="E0E8E9"/>
+                </a:solidFill>
+              </a:rPr>
+              <a:t> RG, Tarun </a:t>
+            </a:r>
+            <a:r>
+              <a:rPr lang="en-IN" sz="1400" dirty="0" err="1">
+                <a:solidFill>
+                  <a:srgbClr val="E0E8E9"/>
+                </a:solidFill>
+              </a:rPr>
+              <a:t>Kondraju</a:t>
+            </a:r>
+            <a:r>
+              <a:rPr lang="en-IN" sz="1400" dirty="0">
+                <a:solidFill>
+                  <a:srgbClr val="E0E8E9"/>
+                </a:solidFill>
+              </a:rPr>
+              <a:t>, Amrita Bhandari</a:t>
+            </a:r>
+            <a:endParaRPr lang="en-US" sz="1400" b="0" i="0" dirty="0">
+              <a:solidFill>
+                <a:srgbClr val="E0E8E9"/>
+              </a:solidFill>
+              <a:latin typeface="Aptos"/>
+            </a:endParaRPr>
           </a:p>
         </p:txBody>
       </p:sp>
@@ -4158,7 +4180,7 @@
       </p:sp>
       <p:sp>
         <p:nvSpPr>
-          <p:cNvPr id="4" name="TextBox 3"/>
+          <p:cNvPr id="40" name="Question Subtitle"/>
           <p:cNvSpPr txBox="1"/>
           <p:nvPr/>
         </p:nvSpPr>
@@ -4180,13 +4202,49 @@
           <a:p>
             <a:pPr algn="l"/>
             <a:r>
-              <a:rPr lang="en-US" sz="1800" b="0" i="1" dirty="0">
+              <a:rPr lang="en-US" sz="1800" b="1" i="0" dirty="0">
+                <a:solidFill>
+                  <a:srgbClr val="1CB8B2"/>
+                </a:solidFill>
+                <a:latin typeface="Aptos"/>
+              </a:rPr>
+              <a:t xml:space="preserve">Q1  </a:t>
+            </a:r>
+            <a:r>
+              <a:rPr lang="en-US" sz="1800" b="0" i="0" dirty="0">
                 <a:solidFill>
                   <a:srgbClr val="33474D"/>
                 </a:solidFill>
                 <a:latin typeface="Aptos"/>
               </a:rPr>
-              <a:t>White rust is seen too late, by eye, plot by plot, so spraying is blanket or late</a:t>
+              <a:t xml:space="preserve">What problem are we solving?</a:t>
+            </a:r>
+            <a:r>
+              <a:rPr lang="en-US" sz="1800" b="0" i="0" dirty="0">
+                <a:solidFill>
+                  <a:srgbClr val="33474D"/>
+                </a:solidFill>
+                <a:latin typeface="Aptos"/>
+              </a:rPr>
+              <a:t xml:space="preserve">     </a:t>
+            </a:r>
+            <a:r>
+              <a:rPr lang="en-US" sz="1800" b="1" i="0" dirty="0">
+                <a:solidFill>
+                  <a:srgbClr val="1CB8B2"/>
+                </a:solidFill>
+                <a:latin typeface="Aptos"/>
+              </a:rPr>
+              <a:t xml:space="preserve">Q2  </a:t>
+            </a:r>
+            <a:r>
+              <a:rPr lang="en-US" sz="1800" b="0" i="0" dirty="0">
+                <a:solidFill>
+                  <a:srgbClr val="33474D"/>
+                </a:solidFill>
+                <a:latin typeface="Aptos"/>
+              </a:rPr>
+              <a:t xml:space="preserve">Who benefits?</a:t>
             </a:r>
           </a:p>
         </p:txBody>
@@ -4446,41 +4504,6 @@
       </p:sp>
       <p:sp>
         <p:nvSpPr>
-          <p:cNvPr id="9" name="TextBox 8"/>
-          <p:cNvSpPr txBox="1"/>
-          <p:nvPr/>
-        </p:nvSpPr>
-        <p:spPr>
-          <a:xfrm>
-            <a:off x="868680" y="5376672"/>
-            <a:ext cx="3063240" cy="274320"/>
-          </a:xfrm>
-          <a:prstGeom prst="rect">
-            <a:avLst/>
-          </a:prstGeom>
-          <a:noFill/>
-        </p:spPr>
-        <p:txBody>
-          <a:bodyPr wrap="square">
-            <a:spAutoFit/>
-          </a:bodyPr>
-          <a:lstStyle/>
-          <a:p>
-            <a:pPr algn="l"/>
-            <a:r>
-              <a:rPr lang="en-US" sz="1100" b="0" i="1" dirty="0">
-                <a:solidFill>
-                  <a:srgbClr val="1CB8B2"/>
-                </a:solidFill>
-                <a:latin typeface="Aptos"/>
-              </a:rPr>
-              <a:t>Gap: no objective field-scale severity map at spray time</a:t>
-            </a:r>
-          </a:p>
-        </p:txBody>
-      </p:sp>
-      <p:sp>
-        <p:nvSpPr>
           <p:cNvPr id="10" name="Rounded Rectangle 9"/>
           <p:cNvSpPr/>
           <p:nvPr/>
@@ -4699,41 +4722,6 @@
       </p:sp>
       <p:sp>
         <p:nvSpPr>
-          <p:cNvPr id="13" name="TextBox 12"/>
-          <p:cNvSpPr txBox="1"/>
-          <p:nvPr/>
-        </p:nvSpPr>
-        <p:spPr>
-          <a:xfrm>
-            <a:off x="4572000" y="5376672"/>
-            <a:ext cx="3063240" cy="274320"/>
-          </a:xfrm>
-          <a:prstGeom prst="rect">
-            <a:avLst/>
-          </a:prstGeom>
-          <a:noFill/>
-        </p:spPr>
-        <p:txBody>
-          <a:bodyPr wrap="square">
-            <a:spAutoFit/>
-          </a:bodyPr>
-          <a:lstStyle/>
-          <a:p>
-            <a:pPr algn="l"/>
-            <a:r>
-              <a:rPr lang="en-US" sz="1100" b="0" i="1" dirty="0">
-                <a:solidFill>
-                  <a:srgbClr val="7DBE4B"/>
-                </a:solidFill>
-                <a:latin typeface="Aptos"/>
-              </a:rPr>
-              <a:t>Priority: smallholders served through FPOs and drone operators</a:t>
-            </a:r>
-          </a:p>
-        </p:txBody>
-      </p:sp>
-      <p:sp>
-        <p:nvSpPr>
           <p:cNvPr id="14" name="Rounded Rectangle 13"/>
           <p:cNvSpPr/>
           <p:nvPr/>
@@ -4916,41 +4904,6 @@
                 <a:latin typeface="Aptos"/>
               </a:rPr>
               <a:t>Drone access is expanding (Kisan Drones, Namo Drone Didi)</a:t>
-            </a:r>
-          </a:p>
-        </p:txBody>
-      </p:sp>
-      <p:sp>
-        <p:nvSpPr>
-          <p:cNvPr id="17" name="TextBox 16"/>
-          <p:cNvSpPr txBox="1"/>
-          <p:nvPr/>
-        </p:nvSpPr>
-        <p:spPr>
-          <a:xfrm>
-            <a:off x="8275320" y="5376672"/>
-            <a:ext cx="3063240" cy="274320"/>
-          </a:xfrm>
-          <a:prstGeom prst="rect">
-            <a:avLst/>
-          </a:prstGeom>
-          <a:noFill/>
-        </p:spPr>
-        <p:txBody>
-          <a:bodyPr wrap="square">
-            <a:spAutoFit/>
-          </a:bodyPr>
-          <a:lstStyle/>
-          <a:p>
-            <a:pPr algn="l"/>
-            <a:r>
-              <a:rPr lang="en-US" sz="1100" b="0" i="1" dirty="0">
-                <a:solidFill>
-                  <a:srgbClr val="1CB8B2"/>
-                </a:solidFill>
-                <a:latin typeface="Aptos"/>
-              </a:rPr>
-              <a:t>Now: AI can turn routine drone flights into decisions</a:t>
             </a:r>
           </a:p>
         </p:txBody>
@@ -5061,7 +5014,7 @@
       </p:sp>
       <p:sp>
         <p:nvSpPr>
-          <p:cNvPr id="4" name="TextBox 3"/>
+          <p:cNvPr id="40" name="Question Subtitle"/>
           <p:cNvSpPr txBox="1"/>
           <p:nvPr/>
         </p:nvSpPr>
@@ -5083,13 +5036,49 @@
           <a:p>
             <a:pPr algn="l"/>
             <a:r>
-              <a:rPr lang="en-US" sz="1800" b="0" i="1" dirty="0">
+              <a:rPr lang="en-US" sz="1800" b="1" i="0" dirty="0">
+                <a:solidFill>
+                  <a:srgbClr val="1CB8B2"/>
+                </a:solidFill>
+                <a:latin typeface="Aptos"/>
+              </a:rPr>
+              <a:t xml:space="preserve">Q3  </a:t>
+            </a:r>
+            <a:r>
+              <a:rPr lang="en-US" sz="1800" b="0" i="0" dirty="0">
                 <a:solidFill>
                   <a:srgbClr val="33474D"/>
                 </a:solidFill>
                 <a:latin typeface="Aptos"/>
               </a:rPr>
-              <a:t>One drone flight → fused sensor features → plot-wise severity and spray map</a:t>
+              <a:t xml:space="preserve">Why does AI make it better?</a:t>
+            </a:r>
+            <a:r>
+              <a:rPr lang="en-US" sz="1800" b="0" i="0" dirty="0">
+                <a:solidFill>
+                  <a:srgbClr val="33474D"/>
+                </a:solidFill>
+                <a:latin typeface="Aptos"/>
+              </a:rPr>
+              <a:t xml:space="preserve">     </a:t>
+            </a:r>
+            <a:r>
+              <a:rPr lang="en-US" sz="1800" b="1" i="0" dirty="0">
+                <a:solidFill>
+                  <a:srgbClr val="1CB8B2"/>
+                </a:solidFill>
+                <a:latin typeface="Aptos"/>
+              </a:rPr>
+              <a:t xml:space="preserve">Q4  </a:t>
+            </a:r>
+            <a:r>
+              <a:rPr lang="en-US" sz="1800" b="0" i="0" dirty="0">
+                <a:solidFill>
+                  <a:srgbClr val="33474D"/>
+                </a:solidFill>
+                <a:latin typeface="Aptos"/>
+              </a:rPr>
+              <a:t xml:space="preserve">How does it work?</a:t>
             </a:r>
           </a:p>
         </p:txBody>
@@ -5228,7 +5217,7 @@
         <p:spPr>
           <a:xfrm>
             <a:off x="868680" y="2510000"/>
-            <a:ext cx="3063240" cy="3474720"/>
+            <a:ext cx="3063240" cy="2139047"/>
           </a:xfrm>
           <a:prstGeom prst="rect">
             <a:avLst/>
@@ -5258,7 +5247,7 @@
                 </a:solidFill>
                 <a:latin typeface="Aptos"/>
               </a:rPr>
-              <a:t>Drone carries RGB, multispectral, thermal, hyperspectral</a:t>
+              <a:t xml:space="preserve">Drone flight with RGB, multispectral, thermal, hyperspectral</a:t>
             </a:r>
           </a:p>
           <a:p>
@@ -5279,7 +5268,7 @@
                 </a:solidFill>
                 <a:latin typeface="Aptos"/>
               </a:rPr>
-              <a:t>Plot or grid-wise severity in 6 classes (Healthy–Very high)</a:t>
+              <a:t xml:space="preserve">AI maps every plot / grid cell into 6 severity classes</a:t>
             </a:r>
           </a:p>
           <a:p>
@@ -5300,7 +5289,7 @@
                 </a:solidFill>
                 <a:latin typeface="Aptos"/>
               </a:rPr>
-              <a:t>Output: geo-referenced map with Skip / Spray / Too-late zones</a:t>
+              <a:t xml:space="preserve">One flight → one geo-referenced spray map: Skip / Spray / Too late</a:t>
             </a:r>
           </a:p>
           <a:p>
@@ -5321,7 +5310,7 @@
                 </a:solidFill>
                 <a:latin typeface="Aptos"/>
               </a:rPr>
-              <a:t>Workflow:</a:t>
+              <a:t xml:space="preserve">Workflow:</a:t>
             </a:r>
             <a:r>
               <a:rPr lang="en-US" sz="1250" b="0" i="0" dirty="0">
@@ -5330,42 +5319,7 @@
                 </a:solidFill>
                 <a:latin typeface="Aptos"/>
               </a:rPr>
-              <a:t> fly → pre-process → features → fuse → classify → map</a:t>
-            </a:r>
-          </a:p>
-        </p:txBody>
-      </p:sp>
-      <p:sp>
-        <p:nvSpPr>
-          <p:cNvPr id="9" name="TextBox 8"/>
-          <p:cNvSpPr txBox="1"/>
-          <p:nvPr/>
-        </p:nvSpPr>
-        <p:spPr>
-          <a:xfrm>
-            <a:off x="868680" y="5376672"/>
-            <a:ext cx="3063240" cy="274320"/>
-          </a:xfrm>
-          <a:prstGeom prst="rect">
-            <a:avLst/>
-          </a:prstGeom>
-          <a:noFill/>
-        </p:spPr>
-        <p:txBody>
-          <a:bodyPr wrap="square">
-            <a:spAutoFit/>
-          </a:bodyPr>
-          <a:lstStyle/>
-          <a:p>
-            <a:pPr algn="l"/>
-            <a:r>
-              <a:rPr lang="en-US" sz="1100" b="0" i="1" dirty="0">
-                <a:solidFill>
-                  <a:srgbClr val="1CB8B2"/>
-                </a:solidFill>
-                <a:latin typeface="Aptos"/>
-              </a:rPr>
-              <a:t>User gets: one flight, one spray map</a:t>
+              <a:t xml:space="preserve"> fly → pre-process → features → fuse → classify → map</a:t>
             </a:r>
           </a:p>
         </p:txBody>
@@ -5460,7 +5414,7 @@
         <p:spPr>
           <a:xfrm>
             <a:off x="4572000" y="2510000"/>
-            <a:ext cx="3063240" cy="3474720"/>
+            <a:ext cx="3063240" cy="1900520"/>
           </a:xfrm>
           <a:prstGeom prst="rect">
             <a:avLst/>
@@ -5490,7 +5444,7 @@
                 </a:solidFill>
                 <a:latin typeface="Aptos"/>
               </a:rPr>
-              <a:t>Phase 1:</a:t>
+              <a:t xml:space="preserve">Why AI:</a:t>
             </a:r>
             <a:r>
               <a:rPr lang="en-US" sz="1250" b="0" i="0" dirty="0">
@@ -5499,7 +5453,7 @@
                 </a:solidFill>
                 <a:latin typeface="Aptos"/>
               </a:rPr>
-              <a:t> disease-specific features (FDR, JM, ReliefF, Boruta)</a:t>
+              <a:t xml:space="preserve"> fuses weak, non-linear signals of 4 sensors that no single index or human eye can combine</a:t>
             </a:r>
           </a:p>
           <a:p>
@@ -5520,7 +5474,7 @@
                 </a:solidFill>
                 <a:latin typeface="Aptos"/>
               </a:rPr>
-              <a:t>Phase 2:</a:t>
+              <a:t xml:space="preserve">Phase 1:</a:t>
             </a:r>
             <a:r>
               <a:rPr lang="en-US" sz="1250" b="0" i="0" dirty="0">
@@ -5529,7 +5483,7 @@
                 </a:solidFill>
                 <a:latin typeface="Aptos"/>
               </a:rPr>
-              <a:t> per-sensor VIF/SPA + SFFS → RF, SVM, KNN</a:t>
+              <a:t xml:space="preserve"> disease-specific features (ANOVA, JM, ReliefF, Boruta)</a:t>
             </a:r>
           </a:p>
           <a:p>
@@ -5550,7 +5504,7 @@
                 </a:solidFill>
                 <a:latin typeface="Aptos"/>
               </a:rPr>
-              <a:t>Phase 3:</a:t>
+              <a:t xml:space="preserve">Phase 2:</a:t>
             </a:r>
             <a:r>
               <a:rPr lang="en-US" sz="1250" b="0" i="0" dirty="0">
@@ -5559,7 +5513,7 @@
                 </a:solidFill>
                 <a:latin typeface="Aptos"/>
               </a:rPr>
-              <a:t> feature-level fusion of all sensors + SFFS</a:t>
+              <a:t xml:space="preserve"> per-sensor VIF/SPA + SFFS → RF, SVM, KNN</a:t>
             </a:r>
           </a:p>
           <a:p>
@@ -5574,13 +5528,22 @@
               <a:buChar char="•"/>
             </a:pPr>
             <a:r>
+              <a:rPr lang="en-US" sz="1250" b="1" i="0" dirty="0">
+                <a:solidFill>
+                  <a:srgbClr val="E0E8E9"/>
+                </a:solidFill>
+                <a:latin typeface="Aptos"/>
+              </a:rPr>
+              <a:t xml:space="preserve">Phase 3:</a:t>
+            </a:r>
+            <a:r>
               <a:rPr lang="en-US" sz="1250" b="0" i="0" dirty="0">
                 <a:solidFill>
                   <a:srgbClr val="E0E8E9"/>
                 </a:solidFill>
                 <a:latin typeface="Aptos"/>
               </a:rPr>
-              <a:t>Nested plot-grouped CV; SHAP explains predictions</a:t>
+              <a:t xml:space="preserve"> feature-level fusion of all sensors + SFFS</a:t>
             </a:r>
           </a:p>
           <a:p>
@@ -5601,7 +5564,7 @@
                 </a:solidFill>
                 <a:latin typeface="Aptos"/>
               </a:rPr>
-              <a:t>Data:</a:t>
+              <a:t xml:space="preserve">Explainable:</a:t>
             </a:r>
             <a:r>
               <a:rPr lang="en-US" sz="1250" b="0" i="0" dirty="0">
@@ -5610,42 +5573,7 @@
                 </a:solidFill>
                 <a:latin typeface="Aptos"/>
               </a:rPr>
-              <a:t> UAV imagery + field Disease Index (0–6 scale)</a:t>
-            </a:r>
-          </a:p>
-        </p:txBody>
-      </p:sp>
-      <p:sp>
-        <p:nvSpPr>
-          <p:cNvPr id="13" name="TextBox 12"/>
-          <p:cNvSpPr txBox="1"/>
-          <p:nvPr/>
-        </p:nvSpPr>
-        <p:spPr>
-          <a:xfrm>
-            <a:off x="4572000" y="5376672"/>
-            <a:ext cx="3063240" cy="274320"/>
-          </a:xfrm>
-          <a:prstGeom prst="rect">
-            <a:avLst/>
-          </a:prstGeom>
-          <a:noFill/>
-        </p:spPr>
-        <p:txBody>
-          <a:bodyPr wrap="square">
-            <a:spAutoFit/>
-          </a:bodyPr>
-          <a:lstStyle/>
-          <a:p>
-            <a:pPr algn="l"/>
-            <a:r>
-              <a:rPr lang="en-US" sz="1100" b="0" i="1" dirty="0">
-                <a:solidFill>
-                  <a:srgbClr val="7DBE4B"/>
-                </a:solidFill>
-                <a:latin typeface="Aptos"/>
-              </a:rPr>
-              <a:t>AI fits: high-dimensional, non-linear multi-sensor signals</a:t>
+              <a:t xml:space="preserve"> SHAP shows which sensor drove each decision</a:t>
             </a:r>
           </a:p>
         </p:txBody>
@@ -5740,7 +5668,7 @@
         <p:spPr>
           <a:xfrm>
             <a:off x="8275320" y="2510000"/>
-            <a:ext cx="3063240" cy="3474720"/>
+            <a:ext cx="3063240" cy="1426031"/>
           </a:xfrm>
           <a:prstGeom prst="rect">
             <a:avLst/>
@@ -5770,7 +5698,7 @@
                 </a:solidFill>
                 <a:latin typeface="Aptos"/>
               </a:rPr>
-              <a:t>First multimodal fusion framework for mustard white rust</a:t>
+              <a:t xml:space="preserve">First multimodal fusion framework for mustard white rust</a:t>
             </a:r>
           </a:p>
           <a:p>
@@ -5791,7 +5719,7 @@
                 </a:solidFill>
                 <a:latin typeface="Aptos"/>
               </a:rPr>
-              <a:t>Interpretable features linked to plant physiology</a:t>
+              <a:t xml:space="preserve">Interpretable features linked to plant physiology</a:t>
             </a:r>
           </a:p>
           <a:p>
@@ -5812,7 +5740,7 @@
                 </a:solidFill>
                 <a:latin typeface="Aptos"/>
               </a:rPr>
-              <a:t>Finds the cheapest sensor set that is accurate enough</a:t>
+              <a:t xml:space="preserve">Finds the cheapest sensor set that is accurate enough</a:t>
             </a:r>
           </a:p>
           <a:p>
@@ -5827,13 +5755,22 @@
               <a:buChar char="•"/>
             </a:pPr>
             <a:r>
+              <a:rPr lang="en-US" sz="1250" b="1" i="0" dirty="0">
+                <a:solidFill>
+                  <a:srgbClr val="E0E8E9"/>
+                </a:solidFill>
+                <a:latin typeface="Aptos"/>
+              </a:rPr>
+              <a:t xml:space="preserve">GI-AI4AFS:</a:t>
+            </a:r>
+            <a:r>
               <a:rPr lang="en-US" sz="1250" b="0" i="0" dirty="0">
                 <a:solidFill>
                   <a:srgbClr val="E0E8E9"/>
                 </a:solidFill>
                 <a:latin typeface="Aptos"/>
               </a:rPr>
-              <a:t>Open Python pipeline; GeoTIFF / GeoPackage outputs</a:t>
+              <a:t xml:space="preserve"> packaged as a Python SDK (appext) extension with API</a:t>
             </a:r>
           </a:p>
           <a:p>
@@ -5854,42 +5791,7 @@
                 </a:solidFill>
                 <a:latin typeface="Aptos"/>
               </a:rPr>
-              <a:t>Can run as a GI-AI4AFS service (API)</a:t>
-            </a:r>
-          </a:p>
-        </p:txBody>
-      </p:sp>
-      <p:sp>
-        <p:nvSpPr>
-          <p:cNvPr id="17" name="TextBox 16"/>
-          <p:cNvSpPr txBox="1"/>
-          <p:nvPr/>
-        </p:nvSpPr>
-        <p:spPr>
-          <a:xfrm>
-            <a:off x="8275320" y="5376672"/>
-            <a:ext cx="3063240" cy="274320"/>
-          </a:xfrm>
-          <a:prstGeom prst="rect">
-            <a:avLst/>
-          </a:prstGeom>
-          <a:noFill/>
-        </p:spPr>
-        <p:txBody>
-          <a:bodyPr wrap="square">
-            <a:spAutoFit/>
-          </a:bodyPr>
-          <a:lstStyle/>
-          <a:p>
-            <a:pPr algn="l"/>
-            <a:r>
-              <a:rPr lang="en-US" sz="1100" b="0" i="1" dirty="0">
-                <a:solidFill>
-                  <a:srgbClr val="1CB8B2"/>
-                </a:solidFill>
-                <a:latin typeface="Aptos"/>
-              </a:rPr>
-              <a:t>Responsible AI: open code, explainable output, data consent</a:t>
+              <a:t xml:space="preserve">Open formats: GeoTIFF in, GeoJSON spray map out</a:t>
             </a:r>
           </a:p>
         </p:txBody>
@@ -6000,7 +5902,7 @@
       </p:sp>
       <p:sp>
         <p:nvSpPr>
-          <p:cNvPr id="4" name="TextBox 3"/>
+          <p:cNvPr id="40" name="Question Subtitle"/>
           <p:cNvSpPr txBox="1"/>
           <p:nvPr/>
         </p:nvSpPr>
@@ -6022,13 +5924,49 @@
           <a:p>
             <a:pPr algn="l"/>
             <a:r>
-              <a:rPr lang="en-US" sz="1800" b="0" i="1" dirty="0">
+              <a:rPr lang="en-US" sz="1800" b="1" i="0" dirty="0">
+                <a:solidFill>
+                  <a:srgbClr val="1CB8B2"/>
+                </a:solidFill>
+                <a:latin typeface="Aptos"/>
+              </a:rPr>
+              <a:t xml:space="preserve">Q5  </a:t>
+            </a:r>
+            <a:r>
+              <a:rPr lang="en-US" sz="1800" b="0" i="0" dirty="0">
                 <a:solidFill>
                   <a:srgbClr val="33474D"/>
                 </a:solidFill>
                 <a:latin typeface="Aptos"/>
               </a:rPr>
-              <a:t>From a 48-plot field trial at IARI to a working severity-mapping prototype</a:t>
+              <a:t xml:space="preserve">Impact and scalability</a:t>
+            </a:r>
+            <a:r>
+              <a:rPr lang="en-US" sz="1800" b="0" i="0" dirty="0">
+                <a:solidFill>
+                  <a:srgbClr val="33474D"/>
+                </a:solidFill>
+                <a:latin typeface="Aptos"/>
+              </a:rPr>
+              <a:t xml:space="preserve">     </a:t>
+            </a:r>
+            <a:r>
+              <a:rPr lang="en-US" sz="1800" b="1" i="0" dirty="0">
+                <a:solidFill>
+                  <a:srgbClr val="1CB8B2"/>
+                </a:solidFill>
+                <a:latin typeface="Aptos"/>
+              </a:rPr>
+              <a:t xml:space="preserve">Demo  </a:t>
+            </a:r>
+            <a:r>
+              <a:rPr lang="en-US" sz="1800" b="0" i="0" dirty="0">
+                <a:solidFill>
+                  <a:srgbClr val="33474D"/>
+                </a:solidFill>
+                <a:latin typeface="Aptos"/>
+              </a:rPr>
+              <a:t xml:space="preserve">Can we show it works?</a:t>
             </a:r>
           </a:p>
         </p:txBody>
@@ -6288,48 +6226,13 @@
       </p:sp>
       <p:sp>
         <p:nvSpPr>
-          <p:cNvPr id="9" name="TextBox 8"/>
-          <p:cNvSpPr txBox="1"/>
-          <p:nvPr/>
-        </p:nvSpPr>
-        <p:spPr>
-          <a:xfrm>
-            <a:off x="868680" y="5376672"/>
-            <a:ext cx="3063240" cy="274320"/>
-          </a:xfrm>
-          <a:prstGeom prst="rect">
-            <a:avLst/>
-          </a:prstGeom>
-          <a:noFill/>
-        </p:spPr>
-        <p:txBody>
-          <a:bodyPr wrap="square">
-            <a:spAutoFit/>
-          </a:bodyPr>
-          <a:lstStyle/>
-          <a:p>
-            <a:pPr algn="l"/>
-            <a:r>
-              <a:rPr lang="en-US" sz="1100" b="0" i="1" dirty="0">
-                <a:solidFill>
-                  <a:srgbClr val="1CB8B2"/>
-                </a:solidFill>
-                <a:latin typeface="Aptos"/>
-              </a:rPr>
-              <a:t>Measure: accuracy, fungicide saved, yield protected</a:t>
-            </a:r>
-          </a:p>
-        </p:txBody>
-      </p:sp>
-      <p:sp>
-        <p:nvSpPr>
           <p:cNvPr id="10" name="Rounded Rectangle 9"/>
           <p:cNvSpPr/>
           <p:nvPr/>
         </p:nvSpPr>
         <p:spPr>
           <a:xfrm>
-            <a:off x="4343400" y="1627632"/>
+            <a:off x="4335780" y="1627632"/>
             <a:ext cx="3520440" cy="4343400"/>
           </a:xfrm>
           <a:prstGeom prst="roundRect">
@@ -6411,7 +6314,7 @@
         <p:spPr>
           <a:xfrm>
             <a:off x="4572000" y="2286000"/>
-            <a:ext cx="3063240" cy="3474720"/>
+            <a:ext cx="3063240" cy="1900520"/>
           </a:xfrm>
           <a:prstGeom prst="rect">
             <a:avLst/>
@@ -6441,7 +6344,7 @@
                 </a:solidFill>
                 <a:latin typeface="Aptos"/>
               </a:rPr>
-              <a:t>IARI trial: 48 plots (12 healthy, 36 inoculated), 4 sensors</a:t>
+              <a:t xml:space="preserve">IARI trial: 48 plots (12 healthy, 36 inoculated), 4 sensors</a:t>
             </a:r>
           </a:p>
           <a:p>
@@ -6462,7 +6365,7 @@
                 </a:solidFill>
                 <a:latin typeface="Aptos"/>
               </a:rPr>
-              <a:t>Python pipeline built and tested end to end</a:t>
+              <a:t xml:space="preserve">Analysis pipeline already coded and tested end to end</a:t>
             </a:r>
           </a:p>
           <a:p>
@@ -6483,7 +6386,7 @@
                 </a:solidFill>
                 <a:latin typeface="Aptos"/>
               </a:rPr>
-              <a:t>3-tier validation: IARI → IIRMR Bharatpur → farmers</a:t>
+              <a:t xml:space="preserve">3-tier validation: IARI → IIRMR Bharatpur → farmers</a:t>
             </a:r>
           </a:p>
           <a:p>
@@ -6504,7 +6407,7 @@
                 </a:solidFill>
                 <a:latin typeface="Aptos"/>
               </a:rPr>
-              <a:t>Retrain with local labels for new regions or diseases</a:t>
+              <a:t xml:space="preserve">Retrain with local labels for new regions or diseases</a:t>
             </a:r>
           </a:p>
           <a:p>
@@ -6525,7 +6428,7 @@
                 </a:solidFill>
                 <a:latin typeface="Aptos"/>
               </a:rPr>
-              <a:t>Partners:</a:t>
+              <a:t xml:space="preserve">Partners:</a:t>
             </a:r>
             <a:r>
               <a:rPr lang="en-US" sz="1250" b="0" i="0" dirty="0">
@@ -6534,42 +6437,7 @@
                 </a:solidFill>
                 <a:latin typeface="Aptos"/>
               </a:rPr>
-              <a:t> ICAR, KVKs, FPOs, drone service providers</a:t>
-            </a:r>
-          </a:p>
-        </p:txBody>
-      </p:sp>
-      <p:sp>
-        <p:nvSpPr>
-          <p:cNvPr id="13" name="TextBox 12"/>
-          <p:cNvSpPr txBox="1"/>
-          <p:nvPr/>
-        </p:nvSpPr>
-        <p:spPr>
-          <a:xfrm>
-            <a:off x="4572000" y="5376672"/>
-            <a:ext cx="3063240" cy="274320"/>
-          </a:xfrm>
-          <a:prstGeom prst="rect">
-            <a:avLst/>
-          </a:prstGeom>
-          <a:noFill/>
-        </p:spPr>
-        <p:txBody>
-          <a:bodyPr wrap="square">
-            <a:spAutoFit/>
-          </a:bodyPr>
-          <a:lstStyle/>
-          <a:p>
-            <a:pPr algn="l"/>
-            <a:r>
-              <a:rPr lang="en-US" sz="1100" b="0" i="1" dirty="0">
-                <a:solidFill>
-                  <a:srgbClr val="7DBE4B"/>
-                </a:solidFill>
-                <a:latin typeface="Aptos"/>
-              </a:rPr>
-              <a:t>Key assumption: canopy signals track severity across sites</a:t>
+              <a:t xml:space="preserve"> ICAR, KVKs, FPOs, drone service providers</a:t>
             </a:r>
           </a:p>
         </p:txBody>
@@ -6664,7 +6532,7 @@
         <p:spPr>
           <a:xfrm>
             <a:off x="8275320" y="2286000"/>
-            <a:ext cx="3063240" cy="3474720"/>
+            <a:ext cx="3063240" cy="2375009"/>
           </a:xfrm>
           <a:prstGeom prst="rect">
             <a:avLst/>
@@ -6688,13 +6556,22 @@
               <a:buChar char="•"/>
             </a:pPr>
             <a:r>
+              <a:rPr lang="en-US" sz="1250" b="1" i="0" dirty="0">
+                <a:solidFill>
+                  <a:srgbClr val="E0E8E9"/>
+                </a:solidFill>
+                <a:latin typeface="Aptos"/>
+              </a:rPr>
+              <a:t xml:space="preserve">Live demo:</a:t>
+            </a:r>
+            <a:r>
               <a:rPr lang="en-US" sz="1250" b="0" i="0" dirty="0">
                 <a:solidFill>
                   <a:srgbClr val="E0E8E9"/>
                 </a:solidFill>
                 <a:latin typeface="Aptos"/>
               </a:rPr>
-              <a:t>Prototype: drone imagery in → severity + spray map out</a:t>
+              <a:t xml:space="preserve"> upload drone images → severity + spray map</a:t>
             </a:r>
           </a:p>
           <a:p>
@@ -6715,7 +6592,7 @@
                 </a:solidFill>
                 <a:latin typeface="Aptos"/>
               </a:rPr>
-              <a:t>Benchmark: single-sensor vs multi-sensor fusion</a:t>
+              <a:t xml:space="preserve">Working GI-AI4AFS extension: API + map viewer</a:t>
             </a:r>
           </a:p>
           <a:p>
@@ -6736,7 +6613,7 @@
                 </a:solidFill>
                 <a:latin typeface="Aptos"/>
               </a:rPr>
-              <a:t>Simple map viewer for FPOs and drone operators</a:t>
+              <a:t xml:space="preserve">Benchmark: single sensor vs multi-sensor fusion</a:t>
             </a:r>
           </a:p>
           <a:p>
@@ -6757,7 +6634,7 @@
                 </a:solidFill>
                 <a:latin typeface="Aptos"/>
               </a:rPr>
-              <a:t>Mentoring needs:</a:t>
+              <a:t xml:space="preserve">Mentoring needs:</a:t>
             </a:r>
             <a:r>
               <a:rPr lang="en-US" sz="1250" b="0" i="0" dirty="0">
@@ -6766,7 +6643,7 @@
                 </a:solidFill>
                 <a:latin typeface="Aptos"/>
               </a:rPr>
-              <a:t> cloud/API deployment, GI-AI4AFS link</a:t>
+              <a:t xml:space="preserve"> cloud deployment, GI-AI4AFS integration</a:t>
             </a:r>
           </a:p>
           <a:p>
@@ -6787,42 +6664,7 @@
                 </a:solidFill>
                 <a:latin typeface="Aptos"/>
               </a:rPr>
-              <a:t>User feedback from FPOs and extension staff</a:t>
-            </a:r>
-          </a:p>
-        </p:txBody>
-      </p:sp>
-      <p:sp>
-        <p:nvSpPr>
-          <p:cNvPr id="17" name="TextBox 16"/>
-          <p:cNvSpPr txBox="1"/>
-          <p:nvPr/>
-        </p:nvSpPr>
-        <p:spPr>
-          <a:xfrm>
-            <a:off x="8275320" y="5376672"/>
-            <a:ext cx="3063240" cy="274320"/>
-          </a:xfrm>
-          <a:prstGeom prst="rect">
-            <a:avLst/>
-          </a:prstGeom>
-          <a:noFill/>
-        </p:spPr>
-        <p:txBody>
-          <a:bodyPr wrap="square">
-            <a:spAutoFit/>
-          </a:bodyPr>
-          <a:lstStyle/>
-          <a:p>
-            <a:pPr algn="l"/>
-            <a:r>
-              <a:rPr lang="en-US" sz="1100" b="0" i="1" dirty="0">
-                <a:solidFill>
-                  <a:srgbClr val="1CB8B2"/>
-                </a:solidFill>
-                <a:latin typeface="Aptos"/>
-              </a:rPr>
-              <a:t>Ask: compute support and FPO / drone-operator partners</a:t>
+              <a:t xml:space="preserve">User feedback from FPOs and extension staff</a:t>
             </a:r>
           </a:p>
         </p:txBody>
@@ -6836,7 +6678,7 @@
 </file>
 
 <file path=ppt/slides/slide5.xml><?xml version="1.0" encoding="utf-8"?>
-<p:sld xmlns:a="http://schemas.openxmlformats.org/drawingml/2006/main" xmlns:r="http://schemas.openxmlformats.org/officeDocument/2006/relationships" xmlns:p="http://schemas.openxmlformats.org/presentationml/2006/main">
+<p:sld xmlns:a="http://schemas.openxmlformats.org/drawingml/2006/main" xmlns:r="http://schemas.openxmlformats.org/officeDocument/2006/relationships" xmlns:p="http://schemas.openxmlformats.org/presentationml/2006/main" show="0">
   <p:cSld>
     <p:spTree>
       <p:nvGrpSpPr>

</xml_diff>